<commit_message>
we produce slides, interwoven, visuals still need helper cleanup, oh joy
</commit_message>
<xml_diff>
--- a/data/input/templates/pptx_template.vis_08.test.pptx
+++ b/data/input/templates/pptx_template.vis_08.test.pptx
@@ -243,7 +243,7 @@
           <a:p>
             <a:fld id="{DC6821C8-422F-4CA2-85E1-19A6D027F030}" type="datetimeFigureOut">
               <a:rPr lang="en-US" smtClean="0"/>
-              <a:t>8/18/2026</a:t>
+              <a:t>8/24/2026</a:t>
             </a:fld>
             <a:endParaRPr lang="en-US"/>
           </a:p>
@@ -431,7 +431,7 @@
             <a:fld id="{68D86595-6E20-4226-9E0D-B3822373F9DE}" type="datetimeFigureOut">
               <a:rPr lang="en-US" smtClean="0"/>
               <a:pPr/>
-              <a:t>8/18/2026</a:t>
+              <a:t>8/24/2026</a:t>
             </a:fld>
             <a:endParaRPr lang="en-US"/>
           </a:p>
@@ -11912,42 +11912,6 @@
           <a:xfrm>
             <a:off x="3023" y="1000506"/>
             <a:ext cx="12188977" cy="228600"/>
-          </a:xfrm>
-          <a:prstGeom prst="rect">
-            <a:avLst/>
-          </a:prstGeom>
-        </p:spPr>
-      </p:pic>
-      <p:pic>
-        <p:nvPicPr>
-          <p:cNvPr id="30" name="vis_tbl01">
-            <a:extLst>
-              <a:ext uri="{FF2B5EF4-FFF2-40B4-BE49-F238E27FC236}">
-                <a16:creationId xmlns:a16="http://schemas.microsoft.com/office/drawing/2014/main" id="{75D3306B-29B3-11A1-6BC0-36BFE1C98E72}"/>
-              </a:ext>
-            </a:extLst>
-          </p:cNvPr>
-          <p:cNvPicPr>
-            <a:picLocks noChangeAspect="1"/>
-          </p:cNvPicPr>
-          <p:nvPr/>
-        </p:nvPicPr>
-        <p:blipFill>
-          <a:blip r:embed="rId7">
-            <a:extLst>
-              <a:ext uri="{28A0092B-C50C-407E-A947-70E740481C1C}">
-                <a14:useLocalDpi xmlns:a14="http://schemas.microsoft.com/office/drawing/2010/main" val="0"/>
-              </a:ext>
-            </a:extLst>
-          </a:blip>
-          <a:stretch>
-            <a:fillRect/>
-          </a:stretch>
-        </p:blipFill>
-        <p:spPr>
-          <a:xfrm>
-            <a:off x="9739117" y="1259255"/>
-            <a:ext cx="2395733" cy="1280163"/>
           </a:xfrm>
           <a:prstGeom prst="rect">
             <a:avLst/>
@@ -13079,6 +13043,15 @@
 </file>
 
 <file path=customXml/item2.xml><?xml version="1.0" encoding="utf-8"?>
+<?mso-contentType ?>
+<FormTemplates xmlns="http://schemas.microsoft.com/sharepoint/v3/contenttype/forms">
+  <Display>DocumentLibraryForm</Display>
+  <Edit>DocumentLibraryForm</Edit>
+  <New>DocumentLibraryForm</New>
+</FormTemplates>
+</file>
+
+<file path=customXml/item3.xml><?xml version="1.0" encoding="utf-8"?>
 <p:properties xmlns:p="http://schemas.microsoft.com/office/2006/metadata/properties" xmlns:xsi="http://www.w3.org/2001/XMLSchema-instance" xmlns:pc="http://schemas.microsoft.com/office/infopath/2007/PartnerControls">
   <documentManagement>
     <lcf76f155ced4ddcb4097134ff3c332f xmlns="05b33221-363d-4d44-afe3-1e10ae3da870">
@@ -13089,15 +13062,6 @@
     <_ip_UnifiedCompliancePolicyProperties xmlns="http://schemas.microsoft.com/sharepoint/v3" xsi:nil="true"/>
   </documentManagement>
 </p:properties>
-</file>
-
-<file path=customXml/item3.xml><?xml version="1.0" encoding="utf-8"?>
-<?mso-contentType ?>
-<FormTemplates xmlns="http://schemas.microsoft.com/sharepoint/v3/contenttype/forms">
-  <Display>DocumentLibraryForm</Display>
-  <Edit>DocumentLibraryForm</Edit>
-  <New>DocumentLibraryForm</New>
-</FormTemplates>
 </file>
 
 <file path=customXml/itemProps1.xml><?xml version="1.0" encoding="utf-8"?>
@@ -13121,6 +13085,14 @@
 </file>
 
 <file path=customXml/itemProps2.xml><?xml version="1.0" encoding="utf-8"?>
+<ds:datastoreItem xmlns:ds="http://schemas.openxmlformats.org/officeDocument/2006/customXml" ds:itemID="{2A1CCD50-0B2F-4685-A6F7-F328002129B4}">
+  <ds:schemaRefs>
+    <ds:schemaRef ds:uri="http://schemas.microsoft.com/sharepoint/v3/contenttype/forms"/>
+  </ds:schemaRefs>
+</ds:datastoreItem>
+</file>
+
+<file path=customXml/itemProps3.xml><?xml version="1.0" encoding="utf-8"?>
 <ds:datastoreItem xmlns:ds="http://schemas.openxmlformats.org/officeDocument/2006/customXml" ds:itemID="{49FE8081-5A08-4CEC-98F7-B9DDB3604F60}">
   <ds:schemaRefs>
     <ds:schemaRef ds:uri="05b33221-363d-4d44-afe3-1e10ae3da870"/>
@@ -13138,14 +13110,6 @@
 </ds:datastoreItem>
 </file>
 
-<file path=customXml/itemProps3.xml><?xml version="1.0" encoding="utf-8"?>
-<ds:datastoreItem xmlns:ds="http://schemas.openxmlformats.org/officeDocument/2006/customXml" ds:itemID="{2A1CCD50-0B2F-4685-A6F7-F328002129B4}">
-  <ds:schemaRefs>
-    <ds:schemaRef ds:uri="http://schemas.microsoft.com/sharepoint/v3/contenttype/forms"/>
-  </ds:schemaRefs>
-</ds:datastoreItem>
-</file>
-
 <file path=docMetadata/LabelInfo.xml><?xml version="1.0" encoding="utf-8"?>
 <clbl:labelList xmlns:clbl="http://schemas.microsoft.com/office/2020/mipLabelMetadata">
   <clbl:label id="{5563d9c4-1af6-4d5e-894d-8f5a4315f709}" enabled="1" method="Privileged" siteId="{3667e201-cbdc-48b3-9b42-5d2d3f16e2a9}" removed="0"/>

</xml_diff>

<commit_message>
we combine visual outputs into one slide!
</commit_message>
<xml_diff>
--- a/data/input/templates/pptx_template.vis_08.test.pptx
+++ b/data/input/templates/pptx_template.vis_08.test.pptx
@@ -243,7 +243,7 @@
           <a:p>
             <a:fld id="{DC6821C8-422F-4CA2-85E1-19A6D027F030}" type="datetimeFigureOut">
               <a:rPr lang="en-US" smtClean="0"/>
-              <a:t>8/24/2026</a:t>
+              <a:t>8/27/2026</a:t>
             </a:fld>
             <a:endParaRPr lang="en-US"/>
           </a:p>
@@ -431,7 +431,7 @@
             <a:fld id="{68D86595-6E20-4226-9E0D-B3822373F9DE}" type="datetimeFigureOut">
               <a:rPr lang="en-US" smtClean="0"/>
               <a:pPr/>
-              <a:t>8/24/2026</a:t>
+              <a:t>8/27/2026</a:t>
             </a:fld>
             <a:endParaRPr lang="en-US"/>
           </a:p>
@@ -11812,7 +11812,7 @@
       </p:sp>
       <p:pic>
         <p:nvPicPr>
-          <p:cNvPr id="13" name="vis_legend">
+          <p:cNvPr id="13" name="vis_08_legend">
             <a:extLst>
               <a:ext uri="{FF2B5EF4-FFF2-40B4-BE49-F238E27FC236}">
                 <a16:creationId xmlns:a16="http://schemas.microsoft.com/office/drawing/2014/main" id="{57D1ED45-B60B-A976-53B5-CA0D01E505C8}"/>
@@ -11838,7 +11838,7 @@
         </p:blipFill>
         <p:spPr>
           <a:xfrm>
-            <a:off x="9728452" y="4832490"/>
+            <a:off x="9785602" y="4832490"/>
             <a:ext cx="2069596" cy="1545339"/>
           </a:xfrm>
           <a:prstGeom prst="rect">
@@ -11848,7 +11848,7 @@
       </p:pic>
       <p:pic>
         <p:nvPicPr>
-          <p:cNvPr id="24" name="vis_image">
+          <p:cNvPr id="24" name="vis_08_image">
             <a:extLst>
               <a:ext uri="{FF2B5EF4-FFF2-40B4-BE49-F238E27FC236}">
                 <a16:creationId xmlns:a16="http://schemas.microsoft.com/office/drawing/2014/main" id="{9823079B-1FE0-72AA-384F-D64AD086BB66}"/>
@@ -11884,7 +11884,7 @@
       </p:pic>
       <p:pic>
         <p:nvPicPr>
-          <p:cNvPr id="28" name="vis_title">
+          <p:cNvPr id="28" name="vis_08_title">
             <a:extLst>
               <a:ext uri="{FF2B5EF4-FFF2-40B4-BE49-F238E27FC236}">
                 <a16:creationId xmlns:a16="http://schemas.microsoft.com/office/drawing/2014/main" id="{D1087F02-0043-F7F0-5CAD-26D416989F96}"/>
@@ -11959,6 +11959,42 @@
           </a:p>
         </p:txBody>
       </p:sp>
+      <p:pic>
+        <p:nvPicPr>
+          <p:cNvPr id="3" name="vis_08_projection_table">
+            <a:extLst>
+              <a:ext uri="{FF2B5EF4-FFF2-40B4-BE49-F238E27FC236}">
+                <a16:creationId xmlns:a16="http://schemas.microsoft.com/office/drawing/2014/main" id="{DE6DD08D-454A-D3AA-AAD8-C3540DED63C9}"/>
+              </a:ext>
+            </a:extLst>
+          </p:cNvPr>
+          <p:cNvPicPr>
+            <a:picLocks noChangeAspect="1"/>
+          </p:cNvPicPr>
+          <p:nvPr/>
+        </p:nvPicPr>
+        <p:blipFill>
+          <a:blip r:embed="rId7">
+            <a:extLst>
+              <a:ext uri="{28A0092B-C50C-407E-A947-70E740481C1C}">
+                <a14:useLocalDpi xmlns:a14="http://schemas.microsoft.com/office/drawing/2010/main" val="0"/>
+              </a:ext>
+            </a:extLst>
+          </a:blip>
+          <a:stretch>
+            <a:fillRect/>
+          </a:stretch>
+        </p:blipFill>
+        <p:spPr>
+          <a:xfrm>
+            <a:off x="9785602" y="1252645"/>
+            <a:ext cx="2395733" cy="1280163"/>
+          </a:xfrm>
+          <a:prstGeom prst="rect">
+            <a:avLst/>
+          </a:prstGeom>
+        </p:spPr>
+      </p:pic>
     </p:spTree>
     <p:custDataLst>
       <p:tags r:id="rId1"/>
@@ -13043,15 +13079,6 @@
 </file>
 
 <file path=customXml/item2.xml><?xml version="1.0" encoding="utf-8"?>
-<?mso-contentType ?>
-<FormTemplates xmlns="http://schemas.microsoft.com/sharepoint/v3/contenttype/forms">
-  <Display>DocumentLibraryForm</Display>
-  <Edit>DocumentLibraryForm</Edit>
-  <New>DocumentLibraryForm</New>
-</FormTemplates>
-</file>
-
-<file path=customXml/item3.xml><?xml version="1.0" encoding="utf-8"?>
 <p:properties xmlns:p="http://schemas.microsoft.com/office/2006/metadata/properties" xmlns:xsi="http://www.w3.org/2001/XMLSchema-instance" xmlns:pc="http://schemas.microsoft.com/office/infopath/2007/PartnerControls">
   <documentManagement>
     <lcf76f155ced4ddcb4097134ff3c332f xmlns="05b33221-363d-4d44-afe3-1e10ae3da870">
@@ -13062,6 +13089,15 @@
     <_ip_UnifiedCompliancePolicyProperties xmlns="http://schemas.microsoft.com/sharepoint/v3" xsi:nil="true"/>
   </documentManagement>
 </p:properties>
+</file>
+
+<file path=customXml/item3.xml><?xml version="1.0" encoding="utf-8"?>
+<?mso-contentType ?>
+<FormTemplates xmlns="http://schemas.microsoft.com/sharepoint/v3/contenttype/forms">
+  <Display>DocumentLibraryForm</Display>
+  <Edit>DocumentLibraryForm</Edit>
+  <New>DocumentLibraryForm</New>
+</FormTemplates>
 </file>
 
 <file path=customXml/itemProps1.xml><?xml version="1.0" encoding="utf-8"?>
@@ -13085,14 +13121,6 @@
 </file>
 
 <file path=customXml/itemProps2.xml><?xml version="1.0" encoding="utf-8"?>
-<ds:datastoreItem xmlns:ds="http://schemas.openxmlformats.org/officeDocument/2006/customXml" ds:itemID="{2A1CCD50-0B2F-4685-A6F7-F328002129B4}">
-  <ds:schemaRefs>
-    <ds:schemaRef ds:uri="http://schemas.microsoft.com/sharepoint/v3/contenttype/forms"/>
-  </ds:schemaRefs>
-</ds:datastoreItem>
-</file>
-
-<file path=customXml/itemProps3.xml><?xml version="1.0" encoding="utf-8"?>
 <ds:datastoreItem xmlns:ds="http://schemas.openxmlformats.org/officeDocument/2006/customXml" ds:itemID="{49FE8081-5A08-4CEC-98F7-B9DDB3604F60}">
   <ds:schemaRefs>
     <ds:schemaRef ds:uri="05b33221-363d-4d44-afe3-1e10ae3da870"/>
@@ -13110,6 +13138,14 @@
 </ds:datastoreItem>
 </file>
 
+<file path=customXml/itemProps3.xml><?xml version="1.0" encoding="utf-8"?>
+<ds:datastoreItem xmlns:ds="http://schemas.openxmlformats.org/officeDocument/2006/customXml" ds:itemID="{2A1CCD50-0B2F-4685-A6F7-F328002129B4}">
+  <ds:schemaRefs>
+    <ds:schemaRef ds:uri="http://schemas.microsoft.com/sharepoint/v3/contenttype/forms"/>
+  </ds:schemaRefs>
+</ds:datastoreItem>
+</file>
+
 <file path=docMetadata/LabelInfo.xml><?xml version="1.0" encoding="utf-8"?>
 <clbl:labelList xmlns:clbl="http://schemas.microsoft.com/office/2020/mipLabelMetadata">
   <clbl:label id="{5563d9c4-1af6-4d5e-894d-8f5a4315f709}" enabled="1" method="Privileged" siteId="{3667e201-cbdc-48b3-9b42-5d2d3f16e2a9}" removed="0"/>

</xml_diff>